<commit_message>
feat(impacto): evolui comprovantes e relatorios da rifa do Sementinha
</commit_message>
<xml_diff>
--- a/public/impacto-no-controle/sementinha/tutorial/passo-a-passo-participar-sementinha.pptx
+++ b/public/impacto-no-controle/sementinha/tutorial/passo-a-passo-participar-sementinha.pptx
@@ -2573,87 +2573,87 @@
           <a:bodyPr wrap="square" rtlCol="0" anchor="ctr"/>
           <a:lstStyle/>
           <a:p>
-            <a:pPr algn="ctr" indent="0" marL="0">
-              <a:buNone/>
-            </a:pPr>
-            <a:r>
-              <a:rPr lang="en-US" sz="1200" b="1" dirty="0">
-                <a:solidFill>
-                  <a:srgbClr val="16542E"/>
-                </a:solidFill>
-              </a:rPr>
-              <a:t>No celular</a:t>
-            </a:r>
-            <a:endParaRPr lang="en-US" sz="1200" dirty="0"/>
-          </a:p>
-        </p:txBody>
-      </p:sp>
-      <p:sp>
-        <p:nvSpPr>
-          <p:cNvPr id="9" name="Text 5"/>
-          <p:cNvSpPr/>
-          <p:nvPr/>
-        </p:nvSpPr>
-        <p:spPr>
-          <a:xfrm>
-            <a:off x="7635240" y="1389888"/>
-            <a:ext cx="3474720" cy="3383280"/>
-          </a:xfrm>
-          <a:prstGeom prst="rect">
-            <a:avLst/>
-          </a:prstGeom>
-          <a:noFill/>
-          <a:ln/>
-        </p:spPr>
-        <p:txBody>
-          <a:bodyPr wrap="square" rtlCol="0" anchor="ctr">
-            <a:normAutofit/>
-          </a:bodyPr>
-          <a:lstStyle/>
-          <a:p>
-            <a:pPr algn="ctr" indent="0" marL="0">
-              <a:buNone/>
-            </a:pPr>
-            <a:r>
-              <a:rPr lang="en-US" sz="1500" dirty="0">
-                <a:solidFill>
-                  <a:srgbClr val="1F2E24"/>
-                </a:solidFill>
-              </a:rPr>
-              <a:t>Campanha</a:t>
-            </a:r>
-            <a:endParaRPr lang="en-US" sz="1500" dirty="0"/>
-          </a:p>
-          <a:p>
-            <a:pPr algn="ctr" indent="0" marL="0">
-              <a:buNone/>
-            </a:pPr>
-            <a:r>
-              <a:rPr lang="en-US" sz="1500" dirty="0">
-                <a:solidFill>
-                  <a:srgbClr val="1F2E24"/>
-                </a:solidFill>
-              </a:rPr>
-              <a:t>PARTICIPE</a:t>
-            </a:r>
-            <a:endParaRPr lang="en-US" sz="1500" dirty="0"/>
-          </a:p>
-          <a:p>
-            <a:pPr algn="ctr" indent="0" marL="0">
-              <a:buNone/>
-            </a:pPr>
-            <a:r>
-              <a:rPr lang="en-US" sz="1500" dirty="0">
-                <a:solidFill>
-                  <a:srgbClr val="1F2E24"/>
-                </a:solidFill>
-              </a:rPr>
-              <a:t>Ver lista</a:t>
-            </a:r>
-            <a:endParaRPr lang="en-US" sz="1500" dirty="0"/>
-          </a:p>
-        </p:txBody>
-      </p:sp>
+            <a:pPr algn="ctr"/>
+            <a:r>
+              <a:rPr sz="1200" b="1">
+                <a:solidFill>
+                  <a:srgbClr val="236F3E"/>
+                </a:solidFill>
+              </a:rPr>
+              <a:t>Tela real do sistema</a:t>
+            </a:r>
+          </a:p>
+        </p:txBody>
+      </p:sp>
+      <p:sp>
+        <p:nvSpPr>
+          <p:cNvPr id="9" name="Rounded Rectangle 8"/>
+          <p:cNvSpPr/>
+          <p:nvPr/>
+        </p:nvSpPr>
+        <p:spPr>
+          <a:xfrm>
+            <a:off x="7635240" y="1325880"/>
+            <a:ext cx="3749039" cy="4617720"/>
+          </a:xfrm>
+          <a:prstGeom prst="roundRect">
+            <a:avLst/>
+          </a:prstGeom>
+          <a:solidFill>
+            <a:srgbClr val="FFFDF7"/>
+          </a:solidFill>
+          <a:ln w="15240">
+            <a:solidFill>
+              <a:srgbClr val="CCD6CA"/>
+            </a:solidFill>
+          </a:ln>
+        </p:spPr>
+        <p:style>
+          <a:lnRef idx="1">
+            <a:schemeClr val="accent1"/>
+          </a:lnRef>
+          <a:fillRef idx="3">
+            <a:schemeClr val="accent1"/>
+          </a:fillRef>
+          <a:effectRef idx="2">
+            <a:schemeClr val="accent1"/>
+          </a:effectRef>
+          <a:fontRef idx="minor">
+            <a:schemeClr val="lt1"/>
+          </a:fontRef>
+        </p:style>
+        <p:txBody>
+          <a:bodyPr rtlCol="0" anchor="ctr"/>
+          <a:lstStyle/>
+          <a:p>
+            <a:pPr algn="ctr"/>
+          </a:p>
+        </p:txBody>
+      </p:sp>
+      <p:pic>
+        <p:nvPicPr>
+          <p:cNvPr id="10" name="Picture 9" descr="image2.jpg"/>
+          <p:cNvPicPr>
+            <a:picLocks noChangeAspect="1"/>
+          </p:cNvPicPr>
+          <p:nvPr/>
+        </p:nvPicPr>
+        <p:blipFill>
+          <a:blip r:embed="rId5"/>
+          <a:stretch>
+            <a:fillRect/>
+          </a:stretch>
+        </p:blipFill>
+        <p:spPr>
+          <a:xfrm>
+            <a:off x="8538667" y="1476756"/>
+            <a:ext cx="1942185" cy="4315968"/>
+          </a:xfrm>
+          <a:prstGeom prst="rect">
+            <a:avLst/>
+          </a:prstGeom>
+        </p:spPr>
+      </p:pic>
     </p:spTree>
   </p:cSld>
   <p:clrMapOvr>
@@ -2920,73 +2920,87 @@
           <a:bodyPr wrap="square" rtlCol="0" anchor="ctr"/>
           <a:lstStyle/>
           <a:p>
-            <a:pPr algn="ctr" indent="0" marL="0">
-              <a:buNone/>
-            </a:pPr>
-            <a:r>
-              <a:rPr lang="en-US" sz="1200" b="1" dirty="0">
-                <a:solidFill>
-                  <a:srgbClr val="16542E"/>
-                </a:solidFill>
-              </a:rPr>
-              <a:t>No celular</a:t>
-            </a:r>
-            <a:endParaRPr lang="en-US" sz="1200" dirty="0"/>
-          </a:p>
-        </p:txBody>
-      </p:sp>
-      <p:sp>
-        <p:nvSpPr>
-          <p:cNvPr id="9" name="Text 5"/>
-          <p:cNvSpPr/>
-          <p:nvPr/>
-        </p:nvSpPr>
-        <p:spPr>
-          <a:xfrm>
-            <a:off x="7635240" y="1389888"/>
-            <a:ext cx="3474720" cy="3383280"/>
-          </a:xfrm>
-          <a:prstGeom prst="rect">
-            <a:avLst/>
-          </a:prstGeom>
-          <a:noFill/>
-          <a:ln/>
-        </p:spPr>
-        <p:txBody>
-          <a:bodyPr wrap="square" rtlCol="0" anchor="ctr">
-            <a:normAutofit/>
-          </a:bodyPr>
-          <a:lstStyle/>
-          <a:p>
-            <a:pPr algn="ctr" indent="0" marL="0">
-              <a:buNone/>
-            </a:pPr>
-            <a:r>
-              <a:rPr lang="en-US" sz="1500" dirty="0">
-                <a:solidFill>
-                  <a:srgbClr val="1F2E24"/>
-                </a:solidFill>
-              </a:rPr>
-              <a:t>Participe da rifa</a:t>
-            </a:r>
-            <a:endParaRPr lang="en-US" sz="1500" dirty="0"/>
-          </a:p>
-          <a:p>
-            <a:pPr algn="ctr" indent="0" marL="0">
-              <a:buNone/>
-            </a:pPr>
-            <a:r>
-              <a:rPr lang="en-US" sz="1500" dirty="0">
-                <a:solidFill>
-                  <a:srgbClr val="1F2E24"/>
-                </a:solidFill>
-              </a:rPr>
-              <a:t>COMECAR</a:t>
-            </a:r>
-            <a:endParaRPr lang="en-US" sz="1500" dirty="0"/>
-          </a:p>
-        </p:txBody>
-      </p:sp>
+            <a:pPr algn="ctr"/>
+            <a:r>
+              <a:rPr sz="1200" b="1">
+                <a:solidFill>
+                  <a:srgbClr val="236F3E"/>
+                </a:solidFill>
+              </a:rPr>
+              <a:t>Tela real do sistema</a:t>
+            </a:r>
+          </a:p>
+        </p:txBody>
+      </p:sp>
+      <p:sp>
+        <p:nvSpPr>
+          <p:cNvPr id="9" name="Rounded Rectangle 8"/>
+          <p:cNvSpPr/>
+          <p:nvPr/>
+        </p:nvSpPr>
+        <p:spPr>
+          <a:xfrm>
+            <a:off x="7635240" y="1325880"/>
+            <a:ext cx="3749039" cy="4617720"/>
+          </a:xfrm>
+          <a:prstGeom prst="roundRect">
+            <a:avLst/>
+          </a:prstGeom>
+          <a:solidFill>
+            <a:srgbClr val="FFFDF7"/>
+          </a:solidFill>
+          <a:ln w="15240">
+            <a:solidFill>
+              <a:srgbClr val="CCD6CA"/>
+            </a:solidFill>
+          </a:ln>
+        </p:spPr>
+        <p:style>
+          <a:lnRef idx="1">
+            <a:schemeClr val="accent1"/>
+          </a:lnRef>
+          <a:fillRef idx="3">
+            <a:schemeClr val="accent1"/>
+          </a:fillRef>
+          <a:effectRef idx="2">
+            <a:schemeClr val="accent1"/>
+          </a:effectRef>
+          <a:fontRef idx="minor">
+            <a:schemeClr val="lt1"/>
+          </a:fontRef>
+        </p:style>
+        <p:txBody>
+          <a:bodyPr rtlCol="0" anchor="ctr"/>
+          <a:lstStyle/>
+          <a:p>
+            <a:pPr algn="ctr"/>
+          </a:p>
+        </p:txBody>
+      </p:sp>
+      <p:pic>
+        <p:nvPicPr>
+          <p:cNvPr id="10" name="Picture 9" descr="image3.jpg"/>
+          <p:cNvPicPr>
+            <a:picLocks noChangeAspect="1"/>
+          </p:cNvPicPr>
+          <p:nvPr/>
+        </p:nvPicPr>
+        <p:blipFill>
+          <a:blip r:embed="rId5"/>
+          <a:stretch>
+            <a:fillRect/>
+          </a:stretch>
+        </p:blipFill>
+        <p:spPr>
+          <a:xfrm>
+            <a:off x="8538245" y="1476756"/>
+            <a:ext cx="1943028" cy="4315968"/>
+          </a:xfrm>
+          <a:prstGeom prst="rect">
+            <a:avLst/>
+          </a:prstGeom>
+        </p:spPr>
+      </p:pic>
     </p:spTree>
   </p:cSld>
   <p:clrMapOvr>
@@ -4230,36 +4244,33 @@
           <a:lstStyle/>
           <a:p>
             <a:r>
-              <a:rPr lang="en-US" sz="1900" dirty="0">
-                <a:solidFill>
-                  <a:srgbClr val="203426"/>
+              <a:rPr sz="2000">
+                <a:solidFill>
+                  <a:srgbClr val="1D2A1F"/>
                 </a:solidFill>
               </a:rPr>
               <a:t>Copie o Pix ou use o QR Code</a:t>
             </a:r>
-            <a:endParaRPr lang="en-US" sz="1900" dirty="0"/>
-          </a:p>
-          <a:p>
-            <a:r>
-              <a:rPr lang="en-US" sz="1900" dirty="0">
-                <a:solidFill>
-                  <a:srgbClr val="203426"/>
-                </a:solidFill>
-              </a:rPr>
-              <a:t>Ou fale com o Suporte</a:t>
-            </a:r>
-            <a:endParaRPr lang="en-US" sz="1900" dirty="0"/>
-          </a:p>
-          <a:p>
-            <a:r>
-              <a:rPr lang="en-US" sz="1900" dirty="0">
-                <a:solidFill>
-                  <a:srgbClr val="203426"/>
-                </a:solidFill>
-              </a:rPr>
-              <a:t>Guarde o link da reserva</a:t>
-            </a:r>
-            <a:endParaRPr lang="en-US" sz="1900" dirty="0"/>
+          </a:p>
+          <a:p>
+            <a:r>
+              <a:rPr sz="2000">
+                <a:solidFill>
+                  <a:srgbClr val="1D2A1F"/>
+                </a:solidFill>
+              </a:rPr>
+              <a:t>Se já fez o Pix, vá direto para ENVIAR COMPROVANTE</a:t>
+            </a:r>
+          </a:p>
+          <a:p>
+            <a:r>
+              <a:rPr sz="2000">
+                <a:solidFill>
+                  <a:srgbClr val="1D2A1F"/>
+                </a:solidFill>
+              </a:rPr>
+              <a:t>Ou fale com o Suporte e guarde o link da reserva</a:t>
+            </a:r>
           </a:p>
         </p:txBody>
       </p:sp>
@@ -4308,87 +4319,87 @@
           <a:bodyPr wrap="square" rtlCol="0" anchor="ctr"/>
           <a:lstStyle/>
           <a:p>
-            <a:pPr algn="ctr" indent="0" marL="0">
-              <a:buNone/>
-            </a:pPr>
-            <a:r>
-              <a:rPr lang="en-US" sz="1200" b="1" dirty="0">
-                <a:solidFill>
-                  <a:srgbClr val="16542E"/>
-                </a:solidFill>
-              </a:rPr>
-              <a:t>No celular</a:t>
-            </a:r>
-            <a:endParaRPr lang="en-US" sz="1200" dirty="0"/>
-          </a:p>
-        </p:txBody>
-      </p:sp>
-      <p:sp>
-        <p:nvSpPr>
-          <p:cNvPr id="9" name="Text 5"/>
-          <p:cNvSpPr/>
-          <p:nvPr/>
-        </p:nvSpPr>
-        <p:spPr>
-          <a:xfrm>
-            <a:off x="7635240" y="1389888"/>
-            <a:ext cx="3474720" cy="3383280"/>
-          </a:xfrm>
-          <a:prstGeom prst="rect">
-            <a:avLst/>
-          </a:prstGeom>
-          <a:noFill/>
-          <a:ln/>
-        </p:spPr>
-        <p:txBody>
-          <a:bodyPr wrap="square" rtlCol="0" anchor="ctr">
-            <a:normAutofit/>
-          </a:bodyPr>
-          <a:lstStyle/>
-          <a:p>
-            <a:pPr algn="ctr" indent="0" marL="0">
-              <a:buNone/>
-            </a:pPr>
-            <a:r>
-              <a:rPr lang="en-US" sz="1500" dirty="0">
-                <a:solidFill>
-                  <a:srgbClr val="1F2E24"/>
-                </a:solidFill>
-              </a:rPr>
-              <a:t>PIX / COMPROVANTE</a:t>
-            </a:r>
-            <a:endParaRPr lang="en-US" sz="1500" dirty="0"/>
-          </a:p>
-          <a:p>
-            <a:pPr algn="ctr" indent="0" marL="0">
-              <a:buNone/>
-            </a:pPr>
-            <a:r>
-              <a:rPr lang="en-US" sz="1500" dirty="0">
-                <a:solidFill>
-                  <a:srgbClr val="1F2E24"/>
-                </a:solidFill>
-              </a:rPr>
-              <a:t>Resumo</a:t>
-            </a:r>
-            <a:endParaRPr lang="en-US" sz="1500" dirty="0"/>
-          </a:p>
-          <a:p>
-            <a:pPr algn="ctr" indent="0" marL="0">
-              <a:buNone/>
-            </a:pPr>
-            <a:r>
-              <a:rPr lang="en-US" sz="1500" dirty="0">
-                <a:solidFill>
-                  <a:srgbClr val="1F2E24"/>
-                </a:solidFill>
-              </a:rPr>
-              <a:t>Pagamento</a:t>
-            </a:r>
-            <a:endParaRPr lang="en-US" sz="1500" dirty="0"/>
-          </a:p>
-        </p:txBody>
-      </p:sp>
+            <a:pPr algn="ctr"/>
+            <a:r>
+              <a:rPr sz="1200" b="1">
+                <a:solidFill>
+                  <a:srgbClr val="236F3E"/>
+                </a:solidFill>
+              </a:rPr>
+              <a:t>Tela real do sistema</a:t>
+            </a:r>
+          </a:p>
+        </p:txBody>
+      </p:sp>
+      <p:sp>
+        <p:nvSpPr>
+          <p:cNvPr id="9" name="Rounded Rectangle 8"/>
+          <p:cNvSpPr/>
+          <p:nvPr/>
+        </p:nvSpPr>
+        <p:spPr>
+          <a:xfrm>
+            <a:off x="7635240" y="1325880"/>
+            <a:ext cx="3749039" cy="4617720"/>
+          </a:xfrm>
+          <a:prstGeom prst="roundRect">
+            <a:avLst/>
+          </a:prstGeom>
+          <a:solidFill>
+            <a:srgbClr val="FFFDF7"/>
+          </a:solidFill>
+          <a:ln w="15240">
+            <a:solidFill>
+              <a:srgbClr val="CCD6CA"/>
+            </a:solidFill>
+          </a:ln>
+        </p:spPr>
+        <p:style>
+          <a:lnRef idx="1">
+            <a:schemeClr val="accent1"/>
+          </a:lnRef>
+          <a:fillRef idx="3">
+            <a:schemeClr val="accent1"/>
+          </a:fillRef>
+          <a:effectRef idx="2">
+            <a:schemeClr val="accent1"/>
+          </a:effectRef>
+          <a:fontRef idx="minor">
+            <a:schemeClr val="lt1"/>
+          </a:fontRef>
+        </p:style>
+        <p:txBody>
+          <a:bodyPr rtlCol="0" anchor="ctr"/>
+          <a:lstStyle/>
+          <a:p>
+            <a:pPr algn="ctr"/>
+          </a:p>
+        </p:txBody>
+      </p:sp>
+      <p:pic>
+        <p:nvPicPr>
+          <p:cNvPr id="10" name="Picture 9" descr="image1.jpg"/>
+          <p:cNvPicPr>
+            <a:picLocks noChangeAspect="1"/>
+          </p:cNvPicPr>
+          <p:nvPr/>
+        </p:nvPicPr>
+        <p:blipFill>
+          <a:blip r:embed="rId5"/>
+          <a:stretch>
+            <a:fillRect/>
+          </a:stretch>
+        </p:blipFill>
+        <p:spPr>
+          <a:xfrm>
+            <a:off x="8495507" y="1476756"/>
+            <a:ext cx="2028504" cy="4315968"/>
+          </a:xfrm>
+          <a:prstGeom prst="rect">
+            <a:avLst/>
+          </a:prstGeom>
+        </p:spPr>
+      </p:pic>
     </p:spTree>
   </p:cSld>
   <p:clrMapOvr>
@@ -4478,18 +4489,14 @@
           <a:bodyPr wrap="square" lIns="254" tIns="254" rIns="254" bIns="254" rtlCol="0" anchor="ctr"/>
           <a:lstStyle/>
           <a:p>
-            <a:pPr indent="0" marL="0">
-              <a:buNone/>
-            </a:pPr>
-            <a:r>
-              <a:rPr lang="en-US" sz="1600" dirty="0">
-                <a:solidFill>
-                  <a:srgbClr val="65726A"/>
-                </a:solidFill>
-              </a:rPr>
-              <a:t>Depois do pagamento, envie um comprovante legível pela própria página.</a:t>
-            </a:r>
-            <a:endParaRPr lang="en-US" sz="1600" dirty="0"/>
+            <a:r>
+              <a:rPr sz="1700">
+                <a:solidFill>
+                  <a:srgbClr val="677269"/>
+                </a:solidFill>
+              </a:rPr>
+              <a:t>Depois do pagamento, envie um comprovante legível pela própria página. Se o Pix já foi feito, use o atalho de envio direto.</a:t>
+            </a:r>
           </a:p>
         </p:txBody>
       </p:sp>

</xml_diff>